<commit_message>
Add move-limit feature and tighten difficulty targets
- Levels now carry min_moves from BFS solver; HTML enforces limit = min_moves + 2 and shows a lose state when exceeded
- finalize_node injects min_moves from QA report into game_config before render
- Streamlit demo path now runs BFS before rendering so move limits work even if sample JSONs omit min_moves
- Tightened Game/Level Designer prompts: minimum 6x6 grids, 2-5 box scaling, layout-driven progression
- Regenerated demo HTML and sample configs with harder solver-verified levels
- Updated Section 3.3 of phase3 report with move-limit feature; added Word version of the report
- Added tools/build_report_pdf.py and tools/build_report_docx.py helpers
</commit_message>
<xml_diff>
--- a/docs/PuzzleForge_Executive_Summary.pptx
+++ b/docs/PuzzleForge_Executive_Summary.pptx
@@ -302,7 +302,7 @@
           <a:p>
             <a:fld id="{5BCAD085-E8A6-8845-BD4E-CB4CCA059FC4}" type="datetimeFigureOut">
               <a:rPr lang="en-US" smtClean="0"/>
-              <a:t>4/14/26</a:t>
+              <a:t>4/20/26</a:t>
             </a:fld>
             <a:endParaRPr lang="en-US"/>
           </a:p>
@@ -470,7 +470,7 @@
           <a:p>
             <a:fld id="{5BCAD085-E8A6-8845-BD4E-CB4CCA059FC4}" type="datetimeFigureOut">
               <a:rPr lang="en-US" smtClean="0"/>
-              <a:t>4/14/26</a:t>
+              <a:t>4/20/26</a:t>
             </a:fld>
             <a:endParaRPr lang="en-US"/>
           </a:p>
@@ -648,7 +648,7 @@
           <a:p>
             <a:fld id="{5BCAD085-E8A6-8845-BD4E-CB4CCA059FC4}" type="datetimeFigureOut">
               <a:rPr lang="en-US" smtClean="0"/>
-              <a:t>4/14/26</a:t>
+              <a:t>4/20/26</a:t>
             </a:fld>
             <a:endParaRPr lang="en-US"/>
           </a:p>
@@ -816,7 +816,7 @@
           <a:p>
             <a:fld id="{5BCAD085-E8A6-8845-BD4E-CB4CCA059FC4}" type="datetimeFigureOut">
               <a:rPr lang="en-US" smtClean="0"/>
-              <a:t>4/14/26</a:t>
+              <a:t>4/20/26</a:t>
             </a:fld>
             <a:endParaRPr lang="en-US"/>
           </a:p>
@@ -1061,7 +1061,7 @@
           <a:p>
             <a:fld id="{5BCAD085-E8A6-8845-BD4E-CB4CCA059FC4}" type="datetimeFigureOut">
               <a:rPr lang="en-US" smtClean="0"/>
-              <a:t>4/14/26</a:t>
+              <a:t>4/20/26</a:t>
             </a:fld>
             <a:endParaRPr lang="en-US"/>
           </a:p>
@@ -1346,7 +1346,7 @@
           <a:p>
             <a:fld id="{5BCAD085-E8A6-8845-BD4E-CB4CCA059FC4}" type="datetimeFigureOut">
               <a:rPr lang="en-US" smtClean="0"/>
-              <a:t>4/14/26</a:t>
+              <a:t>4/20/26</a:t>
             </a:fld>
             <a:endParaRPr lang="en-US"/>
           </a:p>
@@ -1765,7 +1765,7 @@
           <a:p>
             <a:fld id="{5BCAD085-E8A6-8845-BD4E-CB4CCA059FC4}" type="datetimeFigureOut">
               <a:rPr lang="en-US" smtClean="0"/>
-              <a:t>4/14/26</a:t>
+              <a:t>4/20/26</a:t>
             </a:fld>
             <a:endParaRPr lang="en-US"/>
           </a:p>
@@ -1882,7 +1882,7 @@
           <a:p>
             <a:fld id="{5BCAD085-E8A6-8845-BD4E-CB4CCA059FC4}" type="datetimeFigureOut">
               <a:rPr lang="en-US" smtClean="0"/>
-              <a:t>4/14/26</a:t>
+              <a:t>4/20/26</a:t>
             </a:fld>
             <a:endParaRPr lang="en-US"/>
           </a:p>
@@ -1977,7 +1977,7 @@
           <a:p>
             <a:fld id="{5BCAD085-E8A6-8845-BD4E-CB4CCA059FC4}" type="datetimeFigureOut">
               <a:rPr lang="en-US" smtClean="0"/>
-              <a:t>4/14/26</a:t>
+              <a:t>4/20/26</a:t>
             </a:fld>
             <a:endParaRPr lang="en-US"/>
           </a:p>
@@ -2252,7 +2252,7 @@
           <a:p>
             <a:fld id="{5BCAD085-E8A6-8845-BD4E-CB4CCA059FC4}" type="datetimeFigureOut">
               <a:rPr lang="en-US" smtClean="0"/>
-              <a:t>4/14/26</a:t>
+              <a:t>4/20/26</a:t>
             </a:fld>
             <a:endParaRPr lang="en-US"/>
           </a:p>
@@ -2504,7 +2504,7 @@
           <a:p>
             <a:fld id="{5BCAD085-E8A6-8845-BD4E-CB4CCA059FC4}" type="datetimeFigureOut">
               <a:rPr lang="en-US" smtClean="0"/>
-              <a:t>4/14/26</a:t>
+              <a:t>4/20/26</a:t>
             </a:fld>
             <a:endParaRPr lang="en-US"/>
           </a:p>
@@ -2715,7 +2715,7 @@
           <a:p>
             <a:fld id="{5BCAD085-E8A6-8845-BD4E-CB4CCA059FC4}" type="datetimeFigureOut">
               <a:rPr lang="en-US" smtClean="0"/>
-              <a:t>4/14/26</a:t>
+              <a:t>4/20/26</a:t>
             </a:fld>
             <a:endParaRPr lang="en-US"/>
           </a:p>
@@ -3484,7 +3484,7 @@
               </a:spcAft>
             </a:pPr>
             <a:r>
-              <a:rPr sz="1100">
+              <a:rPr sz="1100" dirty="0">
                 <a:solidFill>
                   <a:srgbClr val="E94560"/>
                 </a:solidFill>
@@ -3493,7 +3493,7 @@
               <a:t>▸ </a:t>
             </a:r>
             <a:r>
-              <a:rPr sz="1100" b="1">
+              <a:rPr sz="1100" b="1" dirty="0">
                 <a:solidFill>
                   <a:srgbClr val="BBBBCC"/>
                 </a:solidFill>
@@ -3502,7 +3502,7 @@
               <a:t>Creative + correct: </a:t>
             </a:r>
             <a:r>
-              <a:rPr sz="1100">
+              <a:rPr sz="1100" dirty="0">
                 <a:solidFill>
                   <a:srgbClr val="BBBBCC"/>
                 </a:solidFill>
@@ -3518,7 +3518,7 @@
               </a:spcAft>
             </a:pPr>
             <a:r>
-              <a:rPr sz="1100">
+              <a:rPr sz="1100" dirty="0">
                 <a:solidFill>
                   <a:srgbClr val="E94560"/>
                 </a:solidFill>
@@ -3527,7 +3527,7 @@
               <a:t>▸ </a:t>
             </a:r>
             <a:r>
-              <a:rPr sz="1100" b="1">
+              <a:rPr sz="1100" b="1" dirty="0">
                 <a:solidFill>
                   <a:srgbClr val="BBBBCC"/>
                 </a:solidFill>
@@ -3536,7 +3536,7 @@
               <a:t>LLMs can't verify: </a:t>
             </a:r>
             <a:r>
-              <a:rPr sz="1100">
+              <a:rPr sz="1100" dirty="0">
                 <a:solidFill>
                   <a:srgbClr val="BBBBCC"/>
                 </a:solidFill>
@@ -3552,7 +3552,7 @@
               </a:spcAft>
             </a:pPr>
             <a:r>
-              <a:rPr sz="1100">
+              <a:rPr sz="1100" dirty="0">
                 <a:solidFill>
                   <a:srgbClr val="E94560"/>
                 </a:solidFill>
@@ -3561,7 +3561,7 @@
               <a:t>▸ </a:t>
             </a:r>
             <a:r>
-              <a:rPr sz="1100" b="1">
+              <a:rPr sz="1100" b="1" dirty="0">
                 <a:solidFill>
                   <a:srgbClr val="BBBBCC"/>
                 </a:solidFill>
@@ -3570,7 +3570,7 @@
               <a:t>Slide physics: </a:t>
             </a:r>
             <a:r>
-              <a:rPr sz="1100">
+              <a:rPr sz="1100" dirty="0">
                 <a:solidFill>
                   <a:srgbClr val="BBBBCC"/>
                 </a:solidFill>
@@ -5453,7 +5453,7 @@
         <p:spPr>
           <a:xfrm>
             <a:off x="3977640" y="4023360"/>
-            <a:ext cx="4023360" cy="2560320"/>
+            <a:ext cx="4023360" cy="1938992"/>
           </a:xfrm>
           <a:prstGeom prst="rect">
             <a:avLst/>
@@ -5472,7 +5472,7 @@
               </a:spcAft>
             </a:pPr>
             <a:r>
-              <a:rPr sz="1000">
+              <a:rPr sz="1000" dirty="0">
                 <a:solidFill>
                   <a:srgbClr val="00D2FF"/>
                 </a:solidFill>
@@ -5481,7 +5481,7 @@
               <a:t>▸ </a:t>
             </a:r>
             <a:r>
-              <a:rPr sz="1000" b="1">
+              <a:rPr sz="1000" b="1" dirty="0">
                 <a:solidFill>
                   <a:srgbClr val="BBBBCC"/>
                 </a:solidFill>
@@ -5490,7 +5490,7 @@
               <a:t>Multi-agent failures are emergent. </a:t>
             </a:r>
             <a:r>
-              <a:rPr sz="1000">
+              <a:rPr sz="1000" dirty="0">
                 <a:solidFill>
                   <a:srgbClr val="BBBBCC"/>
                 </a:solidFill>
@@ -5506,7 +5506,7 @@
               </a:spcAft>
             </a:pPr>
             <a:r>
-              <a:rPr sz="1000">
+              <a:rPr sz="1000" dirty="0">
                 <a:solidFill>
                   <a:srgbClr val="00D2FF"/>
                 </a:solidFill>
@@ -5515,7 +5515,7 @@
               <a:t>▸ </a:t>
             </a:r>
             <a:r>
-              <a:rPr sz="1000" b="1">
+              <a:rPr sz="1000" b="1" dirty="0">
                 <a:solidFill>
                   <a:srgbClr val="BBBBCC"/>
                 </a:solidFill>
@@ -5524,7 +5524,7 @@
               <a:t>Silent failure &gt; crash. </a:t>
             </a:r>
             <a:r>
-              <a:rPr sz="1000">
+              <a:rPr sz="1000" dirty="0">
                 <a:solidFill>
                   <a:srgbClr val="BBBBCC"/>
                 </a:solidFill>
@@ -5540,7 +5540,7 @@
               </a:spcAft>
             </a:pPr>
             <a:r>
-              <a:rPr sz="1000">
+              <a:rPr sz="1000" dirty="0">
                 <a:solidFill>
                   <a:srgbClr val="00D2FF"/>
                 </a:solidFill>
@@ -5549,7 +5549,7 @@
               <a:t>▸ </a:t>
             </a:r>
             <a:r>
-              <a:rPr sz="1000" b="1">
+              <a:rPr sz="1000" b="1" dirty="0">
                 <a:solidFill>
                   <a:srgbClr val="BBBBCC"/>
                 </a:solidFill>
@@ -5558,7 +5558,7 @@
               <a:t>Not all failures are equal. </a:t>
             </a:r>
             <a:r>
-              <a:rPr sz="1000">
+              <a:rPr sz="1000" dirty="0">
                 <a:solidFill>
                   <a:srgbClr val="BBBBCC"/>
                 </a:solidFill>
@@ -5574,7 +5574,7 @@
               </a:spcAft>
             </a:pPr>
             <a:r>
-              <a:rPr sz="1000">
+              <a:rPr sz="1000" dirty="0">
                 <a:solidFill>
                   <a:srgbClr val="00D2FF"/>
                 </a:solidFill>
@@ -5583,7 +5583,7 @@
               <a:t>▸ </a:t>
             </a:r>
             <a:r>
-              <a:rPr sz="1000" b="1">
+              <a:rPr sz="1000" b="1" dirty="0">
                 <a:solidFill>
                   <a:srgbClr val="BBBBCC"/>
                 </a:solidFill>
@@ -5592,7 +5592,7 @@
               <a:t>Verification beats prompting. </a:t>
             </a:r>
             <a:r>
-              <a:rPr sz="1000">
+              <a:rPr sz="1000" dirty="0">
                 <a:solidFill>
                   <a:srgbClr val="BBBBCC"/>
                 </a:solidFill>
@@ -5608,7 +5608,7 @@
               </a:spcAft>
             </a:pPr>
             <a:r>
-              <a:rPr sz="1000">
+              <a:rPr sz="1000" dirty="0">
                 <a:solidFill>
                   <a:srgbClr val="00D2FF"/>
                 </a:solidFill>
@@ -5617,7 +5617,7 @@
               <a:t>▸ </a:t>
             </a:r>
             <a:r>
-              <a:rPr sz="1000" b="1">
+              <a:rPr sz="1000" b="1" dirty="0">
                 <a:solidFill>
                   <a:srgbClr val="BBBBCC"/>
                 </a:solidFill>
@@ -5626,7 +5626,7 @@
               <a:t>Observability pays for itself. </a:t>
             </a:r>
             <a:r>
-              <a:rPr sz="1000">
+              <a:rPr sz="1000" dirty="0">
                 <a:solidFill>
                   <a:srgbClr val="BBBBCC"/>
                 </a:solidFill>
@@ -6032,6 +6032,38 @@
             <a:r>
               <a:t>8 failures documented  ·  11 test cases  ·  4 live pipeline runs  ·  Baseline comparison  ·  BFS solver ground truth</a:t>
             </a:r>
+          </a:p>
+        </p:txBody>
+      </p:sp>
+      <p:sp>
+        <p:nvSpPr>
+          <p:cNvPr id="50" name="文本框 49">
+            <a:extLst>
+              <a:ext uri="{FF2B5EF4-FFF2-40B4-BE49-F238E27FC236}">
+                <a16:creationId xmlns:a16="http://schemas.microsoft.com/office/drawing/2014/main" id="{8902B135-5670-4BD9-E819-148C3AA3A31C}"/>
+              </a:ext>
+            </a:extLst>
+          </p:cNvPr>
+          <p:cNvSpPr txBox="1"/>
+          <p:nvPr/>
+        </p:nvSpPr>
+        <p:spPr>
+          <a:xfrm>
+            <a:off x="354330" y="3520440"/>
+            <a:ext cx="184731" cy="369332"/>
+          </a:xfrm>
+          <a:prstGeom prst="rect">
+            <a:avLst/>
+          </a:prstGeom>
+          <a:noFill/>
+        </p:spPr>
+        <p:txBody>
+          <a:bodyPr wrap="none" rtlCol="0">
+            <a:spAutoFit/>
+          </a:bodyPr>
+          <a:lstStyle/>
+          <a:p>
+            <a:endParaRPr kumimoji="1" lang="zh-CN" altLang="en-US"/>
           </a:p>
         </p:txBody>
       </p:sp>

</xml_diff>